<commit_message>
docs(apresentacoes): atualiza os diagramas embutidos nos decks
Os decks 02, 03 e 06 ainda traziam os diagramas anteriores aos
fluxogramas com raias horizontais. Troca as 7 imagens pelas versões
atuais de assets/diagramas e ajusta os slides às novas proporções:

- 02: arquitetura da solução (slide 3) e ciclo do pedido (slide 8)
- 03: endereço pelo CEP (24 e 26), registro do pedido (40),
  pagamento (51) e cancelamento e reembolso (53); nos slides 24, 40
  e 53 o diagrama vai para o alto e os itens ficam em linha abaixo; no
  51, tabela de cenários e destaque lado a lado abaixo do diagrama
- 06: arquitetura na SAP BTP (slide 19)

As capturas de tela dos decks 04 e 05 já estavam atualizadas.

Co-Authored-By: Claude Opus 5.5 <noreply@anthropic.com>
</commit_message>
<xml_diff>
--- a/docs/apresentacoes/02-servicos-odata.pptx
+++ b/docs/apresentacoes/02-servicos-odata.pptx
@@ -35867,8 +35867,8 @@
         </p:nvSpPr>
         <p:spPr>
           <a:xfrm>
-            <a:off x="990758" y="1463040"/>
-            <a:ext cx="6065204" cy="4800600"/>
+            <a:off x="548640" y="2030431"/>
+            <a:ext cx="6949440" cy="3665817"/>
           </a:xfrm>
           <a:prstGeom prst="roundRect">
             <a:avLst>
@@ -35909,8 +35909,8 @@
         </p:blipFill>
         <p:spPr>
           <a:xfrm>
-            <a:off x="1082198" y="1554480"/>
-            <a:ext cx="5882324" cy="4617720"/>
+            <a:off x="640080" y="2121871"/>
+            <a:ext cx="6766560" cy="3482937"/>
           </a:xfrm>
           <a:prstGeom prst="rect">
             <a:avLst/>
@@ -51650,8 +51650,8 @@
         </p:nvSpPr>
         <p:spPr>
           <a:xfrm>
-            <a:off x="1490950" y="1463040"/>
-            <a:ext cx="9207052" cy="4800600"/>
+            <a:off x="1821980" y="1463040"/>
+            <a:ext cx="8544992" cy="4800600"/>
           </a:xfrm>
           <a:prstGeom prst="roundRect">
             <a:avLst>
@@ -51692,8 +51692,8 @@
         </p:blipFill>
         <p:spPr>
           <a:xfrm>
-            <a:off x="1582390" y="1554480"/>
-            <a:ext cx="9024172" cy="4617720"/>
+            <a:off x="1913420" y="1554480"/>
+            <a:ext cx="8362112" cy="4617720"/>
           </a:xfrm>
           <a:prstGeom prst="rect">
             <a:avLst/>

</xml_diff>